<commit_message>
Let's try it this way
</commit_message>
<xml_diff>
--- a/templates/MonthlyReqsTemplate.pptx
+++ b/templates/MonthlyReqsTemplate.pptx
@@ -6,6 +6,10 @@
   </p:sldMasterIdLst>
   <p:sldIdLst>
     <p:sldId id="256" r:id="rId2"/>
+    <p:sldId id="260" r:id="rId3"/>
+    <p:sldId id="259" r:id="rId4"/>
+    <p:sldId id="258" r:id="rId5"/>
+    <p:sldId id="257" r:id="rId6"/>
   </p:sldIdLst>
   <p:sldSz cx="9144000" cy="6858000" type="screen4x3"/>
   <p:notesSz cx="6858000" cy="9144000"/>
@@ -104,7 +108,69 @@
       </a:defRPr>
     </a:lvl9pPr>
   </p:defaultTextStyle>
+  <p:extLst>
+    <p:ext uri="{EFAFB233-063F-42B5-8137-9DF3F51BA10A}">
+      <p15:sldGuideLst xmlns:p15="http://schemas.microsoft.com/office/powerpoint/2012/main"/>
+    </p:ext>
+  </p:extLst>
 </p:presentation>
+</file>
+
+<file path=ppt/changesInfos/changesInfo1.xml><?xml version="1.0" encoding="utf-8"?>
+<pc:chgInfo xmlns:a="http://schemas.openxmlformats.org/drawingml/2006/main" xmlns:r="http://schemas.openxmlformats.org/officeDocument/2006/relationships" xmlns:ac="http://schemas.microsoft.com/office/drawing/2013/main/command" xmlns:pc="http://schemas.microsoft.com/office/powerpoint/2013/main/command">
+  <pc:docChgLst>
+    <pc:chgData name="Smith, Kevin T CIV (USA)" userId="cae5e24e-0f8e-41d3-a8a1-11b4966fd3c3" providerId="ADAL" clId="{42E898A4-AE19-47CE-A2DC-3DFC9C9D6759}"/>
+    <pc:docChg chg="undo custSel addSld modSld">
+      <pc:chgData name="Smith, Kevin T CIV (USA)" userId="cae5e24e-0f8e-41d3-a8a1-11b4966fd3c3" providerId="ADAL" clId="{42E898A4-AE19-47CE-A2DC-3DFC9C9D6759}" dt="2026-03-12T15:12:27.504" v="5" actId="2890"/>
+      <pc:docMkLst>
+        <pc:docMk/>
+      </pc:docMkLst>
+      <pc:sldChg chg="addSp delSp mod">
+        <pc:chgData name="Smith, Kevin T CIV (USA)" userId="cae5e24e-0f8e-41d3-a8a1-11b4966fd3c3" providerId="ADAL" clId="{42E898A4-AE19-47CE-A2DC-3DFC9C9D6759}" dt="2026-03-12T15:12:15.832" v="1" actId="22"/>
+        <pc:sldMkLst>
+          <pc:docMk/>
+          <pc:sldMk cId="2909057856" sldId="256"/>
+        </pc:sldMkLst>
+        <pc:spChg chg="add del">
+          <ac:chgData name="Smith, Kevin T CIV (USA)" userId="cae5e24e-0f8e-41d3-a8a1-11b4966fd3c3" providerId="ADAL" clId="{42E898A4-AE19-47CE-A2DC-3DFC9C9D6759}" dt="2026-03-12T15:12:15.832" v="1" actId="22"/>
+          <ac:spMkLst>
+            <pc:docMk/>
+            <pc:sldMk cId="2909057856" sldId="256"/>
+            <ac:spMk id="3" creationId="{6A6A100C-30AE-F52B-D097-DD26CC7CF51C}"/>
+          </ac:spMkLst>
+        </pc:spChg>
+      </pc:sldChg>
+      <pc:sldChg chg="add">
+        <pc:chgData name="Smith, Kevin T CIV (USA)" userId="cae5e24e-0f8e-41d3-a8a1-11b4966fd3c3" providerId="ADAL" clId="{42E898A4-AE19-47CE-A2DC-3DFC9C9D6759}" dt="2026-03-12T15:12:20.187" v="2" actId="2890"/>
+        <pc:sldMkLst>
+          <pc:docMk/>
+          <pc:sldMk cId="3753486991" sldId="257"/>
+        </pc:sldMkLst>
+      </pc:sldChg>
+      <pc:sldChg chg="add">
+        <pc:chgData name="Smith, Kevin T CIV (USA)" userId="cae5e24e-0f8e-41d3-a8a1-11b4966fd3c3" providerId="ADAL" clId="{42E898A4-AE19-47CE-A2DC-3DFC9C9D6759}" dt="2026-03-12T15:12:22.959" v="3" actId="2890"/>
+        <pc:sldMkLst>
+          <pc:docMk/>
+          <pc:sldMk cId="464938641" sldId="258"/>
+        </pc:sldMkLst>
+      </pc:sldChg>
+      <pc:sldChg chg="add">
+        <pc:chgData name="Smith, Kevin T CIV (USA)" userId="cae5e24e-0f8e-41d3-a8a1-11b4966fd3c3" providerId="ADAL" clId="{42E898A4-AE19-47CE-A2DC-3DFC9C9D6759}" dt="2026-03-12T15:12:25.105" v="4" actId="2890"/>
+        <pc:sldMkLst>
+          <pc:docMk/>
+          <pc:sldMk cId="123626895" sldId="259"/>
+        </pc:sldMkLst>
+      </pc:sldChg>
+      <pc:sldChg chg="add">
+        <pc:chgData name="Smith, Kevin T CIV (USA)" userId="cae5e24e-0f8e-41d3-a8a1-11b4966fd3c3" providerId="ADAL" clId="{42E898A4-AE19-47CE-A2DC-3DFC9C9D6759}" dt="2026-03-12T15:12:27.504" v="5" actId="2890"/>
+        <pc:sldMkLst>
+          <pc:docMk/>
+          <pc:sldMk cId="456530037" sldId="260"/>
+        </pc:sldMkLst>
+      </pc:sldChg>
+    </pc:docChg>
+  </pc:docChgLst>
+</pc:chgInfo>
 </file>
 
 <file path=ppt/slideLayouts/slideLayout1.xml><?xml version="1.0" encoding="utf-8"?>
@@ -238,7 +304,7 @@
           <a:p>
             <a:fld id="{1E4CCFF7-9635-4A2C-B5B5-518B357BFA4A}" type="datetimeFigureOut">
               <a:rPr lang="en-US" smtClean="0"/>
-              <a:t>3/10/2026</a:t>
+              <a:t>3/12/2026</a:t>
             </a:fld>
             <a:endParaRPr lang="en-US"/>
           </a:p>
@@ -408,7 +474,7 @@
           <a:p>
             <a:fld id="{1E4CCFF7-9635-4A2C-B5B5-518B357BFA4A}" type="datetimeFigureOut">
               <a:rPr lang="en-US" smtClean="0"/>
-              <a:t>3/10/2026</a:t>
+              <a:t>3/12/2026</a:t>
             </a:fld>
             <a:endParaRPr lang="en-US"/>
           </a:p>
@@ -588,7 +654,7 @@
           <a:p>
             <a:fld id="{1E4CCFF7-9635-4A2C-B5B5-518B357BFA4A}" type="datetimeFigureOut">
               <a:rPr lang="en-US" smtClean="0"/>
-              <a:t>3/10/2026</a:t>
+              <a:t>3/12/2026</a:t>
             </a:fld>
             <a:endParaRPr lang="en-US"/>
           </a:p>
@@ -758,7 +824,7 @@
           <a:p>
             <a:fld id="{1E4CCFF7-9635-4A2C-B5B5-518B357BFA4A}" type="datetimeFigureOut">
               <a:rPr lang="en-US" smtClean="0"/>
-              <a:t>3/10/2026</a:t>
+              <a:t>3/12/2026</a:t>
             </a:fld>
             <a:endParaRPr lang="en-US"/>
           </a:p>
@@ -1004,7 +1070,7 @@
           <a:p>
             <a:fld id="{1E4CCFF7-9635-4A2C-B5B5-518B357BFA4A}" type="datetimeFigureOut">
               <a:rPr lang="en-US" smtClean="0"/>
-              <a:t>3/10/2026</a:t>
+              <a:t>3/12/2026</a:t>
             </a:fld>
             <a:endParaRPr lang="en-US"/>
           </a:p>
@@ -1236,7 +1302,7 @@
           <a:p>
             <a:fld id="{1E4CCFF7-9635-4A2C-B5B5-518B357BFA4A}" type="datetimeFigureOut">
               <a:rPr lang="en-US" smtClean="0"/>
-              <a:t>3/10/2026</a:t>
+              <a:t>3/12/2026</a:t>
             </a:fld>
             <a:endParaRPr lang="en-US"/>
           </a:p>
@@ -1603,7 +1669,7 @@
           <a:p>
             <a:fld id="{1E4CCFF7-9635-4A2C-B5B5-518B357BFA4A}" type="datetimeFigureOut">
               <a:rPr lang="en-US" smtClean="0"/>
-              <a:t>3/10/2026</a:t>
+              <a:t>3/12/2026</a:t>
             </a:fld>
             <a:endParaRPr lang="en-US"/>
           </a:p>
@@ -1721,7 +1787,7 @@
           <a:p>
             <a:fld id="{1E4CCFF7-9635-4A2C-B5B5-518B357BFA4A}" type="datetimeFigureOut">
               <a:rPr lang="en-US" smtClean="0"/>
-              <a:t>3/10/2026</a:t>
+              <a:t>3/12/2026</a:t>
             </a:fld>
             <a:endParaRPr lang="en-US"/>
           </a:p>
@@ -1816,7 +1882,7 @@
           <a:p>
             <a:fld id="{1E4CCFF7-9635-4A2C-B5B5-518B357BFA4A}" type="datetimeFigureOut">
               <a:rPr lang="en-US" smtClean="0"/>
-              <a:t>3/10/2026</a:t>
+              <a:t>3/12/2026</a:t>
             </a:fld>
             <a:endParaRPr lang="en-US"/>
           </a:p>
@@ -2093,7 +2159,7 @@
           <a:p>
             <a:fld id="{1E4CCFF7-9635-4A2C-B5B5-518B357BFA4A}" type="datetimeFigureOut">
               <a:rPr lang="en-US" smtClean="0"/>
-              <a:t>3/10/2026</a:t>
+              <a:t>3/12/2026</a:t>
             </a:fld>
             <a:endParaRPr lang="en-US"/>
           </a:p>
@@ -2350,7 +2416,7 @@
           <a:p>
             <a:fld id="{1E4CCFF7-9635-4A2C-B5B5-518B357BFA4A}" type="datetimeFigureOut">
               <a:rPr lang="en-US" smtClean="0"/>
-              <a:t>3/10/2026</a:t>
+              <a:t>3/12/2026</a:t>
             </a:fld>
             <a:endParaRPr lang="en-US"/>
           </a:p>
@@ -2563,7 +2629,7 @@
           <a:p>
             <a:fld id="{1E4CCFF7-9635-4A2C-B5B5-518B357BFA4A}" type="datetimeFigureOut">
               <a:rPr lang="en-US" smtClean="0"/>
-              <a:t>3/10/2026</a:t>
+              <a:t>3/12/2026</a:t>
             </a:fld>
             <a:endParaRPr lang="en-US"/>
           </a:p>
@@ -3111,6 +3177,670 @@
 </p:sld>
 </file>
 
+<file path=ppt/slides/slide2.xml><?xml version="1.0" encoding="utf-8"?>
+<p:sld xmlns:a="http://schemas.openxmlformats.org/drawingml/2006/main" xmlns:r="http://schemas.openxmlformats.org/officeDocument/2006/relationships" xmlns:p="http://schemas.openxmlformats.org/presentationml/2006/main">
+  <p:cSld>
+    <p:spTree>
+      <p:nvGrpSpPr>
+        <p:cNvPr id="1" name="">
+          <a:extLst>
+            <a:ext uri="{FF2B5EF4-FFF2-40B4-BE49-F238E27FC236}">
+              <a16:creationId xmlns:a16="http://schemas.microsoft.com/office/drawing/2014/main" id="{60CCD694-9120-98AF-CE5A-A65B8821164C}"/>
+            </a:ext>
+          </a:extLst>
+        </p:cNvPr>
+        <p:cNvGrpSpPr/>
+        <p:nvPr/>
+      </p:nvGrpSpPr>
+      <p:grpSpPr>
+        <a:xfrm>
+          <a:off x="0" y="0"/>
+          <a:ext cx="0" cy="0"/>
+          <a:chOff x="0" y="0"/>
+          <a:chExt cx="0" cy="0"/>
+        </a:xfrm>
+      </p:grpSpPr>
+      <p:pic>
+        <p:nvPicPr>
+          <p:cNvPr id="7" name="Picture 6" descr="A picture containing group, colorful">
+            <a:extLst>
+              <a:ext uri="{FF2B5EF4-FFF2-40B4-BE49-F238E27FC236}">
+                <a16:creationId xmlns:a16="http://schemas.microsoft.com/office/drawing/2014/main" id="{27D6E544-E243-1E23-5E7C-8A03C16A7533}"/>
+              </a:ext>
+            </a:extLst>
+          </p:cNvPr>
+          <p:cNvPicPr>
+            <a:picLocks noChangeAspect="1"/>
+          </p:cNvPicPr>
+          <p:nvPr/>
+        </p:nvPicPr>
+        <p:blipFill>
+          <a:blip r:embed="rId2">
+            <a:extLst>
+              <a:ext uri="{28A0092B-C50C-407E-A947-70E740481C1C}">
+                <a14:useLocalDpi xmlns:a14="http://schemas.microsoft.com/office/drawing/2010/main" val="0"/>
+              </a:ext>
+            </a:extLst>
+          </a:blip>
+          <a:stretch>
+            <a:fillRect/>
+          </a:stretch>
+        </p:blipFill>
+        <p:spPr>
+          <a:xfrm>
+            <a:off x="0" y="0"/>
+            <a:ext cx="9144000" cy="1343891"/>
+          </a:xfrm>
+          <a:prstGeom prst="rect">
+            <a:avLst/>
+          </a:prstGeom>
+        </p:spPr>
+      </p:pic>
+      <p:sp>
+        <p:nvSpPr>
+          <p:cNvPr id="8" name="TextBox 7">
+            <a:extLst>
+              <a:ext uri="{FF2B5EF4-FFF2-40B4-BE49-F238E27FC236}">
+                <a16:creationId xmlns:a16="http://schemas.microsoft.com/office/drawing/2014/main" id="{E10B51B4-C20E-42D8-4D6D-4B7A899CF7BD}"/>
+              </a:ext>
+            </a:extLst>
+          </p:cNvPr>
+          <p:cNvSpPr txBox="1"/>
+          <p:nvPr/>
+        </p:nvSpPr>
+        <p:spPr>
+          <a:xfrm>
+            <a:off x="2207936" y="6411247"/>
+            <a:ext cx="4728129" cy="307777"/>
+          </a:xfrm>
+          <a:prstGeom prst="rect">
+            <a:avLst/>
+          </a:prstGeom>
+          <a:solidFill>
+            <a:schemeClr val="bg1"/>
+          </a:solidFill>
+          <a:ln>
+            <a:solidFill>
+              <a:schemeClr val="tx1"/>
+            </a:solidFill>
+          </a:ln>
+        </p:spPr>
+        <p:txBody>
+          <a:bodyPr wrap="square" rtlCol="0">
+            <a:spAutoFit/>
+          </a:bodyPr>
+          <a:lstStyle/>
+          <a:p>
+            <a:pPr algn="ctr"/>
+            <a:r>
+              <a:rPr lang="en-US" sz="1400" dirty="0">
+                <a:solidFill>
+                  <a:srgbClr val="C00000"/>
+                </a:solidFill>
+              </a:rPr>
+              <a:t>Controlled Unclassified Information (CUI)</a:t>
+            </a:r>
+          </a:p>
+        </p:txBody>
+      </p:sp>
+      <p:sp>
+        <p:nvSpPr>
+          <p:cNvPr id="9" name="TextBox 8">
+            <a:extLst>
+              <a:ext uri="{FF2B5EF4-FFF2-40B4-BE49-F238E27FC236}">
+                <a16:creationId xmlns:a16="http://schemas.microsoft.com/office/drawing/2014/main" id="{F237424C-E608-5450-601A-9DB1EC2B008D}"/>
+              </a:ext>
+            </a:extLst>
+          </p:cNvPr>
+          <p:cNvSpPr txBox="1"/>
+          <p:nvPr/>
+        </p:nvSpPr>
+        <p:spPr>
+          <a:xfrm>
+            <a:off x="2207936" y="36576"/>
+            <a:ext cx="4728129" cy="307777"/>
+          </a:xfrm>
+          <a:prstGeom prst="rect">
+            <a:avLst/>
+          </a:prstGeom>
+          <a:solidFill>
+            <a:schemeClr val="bg1"/>
+          </a:solidFill>
+          <a:ln>
+            <a:solidFill>
+              <a:schemeClr val="tx1"/>
+            </a:solidFill>
+          </a:ln>
+        </p:spPr>
+        <p:txBody>
+          <a:bodyPr wrap="square" rtlCol="0">
+            <a:spAutoFit/>
+          </a:bodyPr>
+          <a:lstStyle/>
+          <a:p>
+            <a:pPr algn="ctr"/>
+            <a:r>
+              <a:rPr lang="en-US" sz="1400" dirty="0">
+                <a:solidFill>
+                  <a:srgbClr val="C00000"/>
+                </a:solidFill>
+              </a:rPr>
+              <a:t>Controlled Unclassified Information (CUI)</a:t>
+            </a:r>
+          </a:p>
+        </p:txBody>
+      </p:sp>
+    </p:spTree>
+    <p:extLst>
+      <p:ext uri="{BB962C8B-B14F-4D97-AF65-F5344CB8AC3E}">
+        <p14:creationId xmlns:p14="http://schemas.microsoft.com/office/powerpoint/2010/main" val="456530037"/>
+      </p:ext>
+    </p:extLst>
+  </p:cSld>
+  <p:clrMapOvr>
+    <a:masterClrMapping/>
+  </p:clrMapOvr>
+</p:sld>
+</file>
+
+<file path=ppt/slides/slide3.xml><?xml version="1.0" encoding="utf-8"?>
+<p:sld xmlns:a="http://schemas.openxmlformats.org/drawingml/2006/main" xmlns:r="http://schemas.openxmlformats.org/officeDocument/2006/relationships" xmlns:p="http://schemas.openxmlformats.org/presentationml/2006/main">
+  <p:cSld>
+    <p:spTree>
+      <p:nvGrpSpPr>
+        <p:cNvPr id="1" name="">
+          <a:extLst>
+            <a:ext uri="{FF2B5EF4-FFF2-40B4-BE49-F238E27FC236}">
+              <a16:creationId xmlns:a16="http://schemas.microsoft.com/office/drawing/2014/main" id="{2E0645D7-4932-C74E-CEE6-E4D9708374C8}"/>
+            </a:ext>
+          </a:extLst>
+        </p:cNvPr>
+        <p:cNvGrpSpPr/>
+        <p:nvPr/>
+      </p:nvGrpSpPr>
+      <p:grpSpPr>
+        <a:xfrm>
+          <a:off x="0" y="0"/>
+          <a:ext cx="0" cy="0"/>
+          <a:chOff x="0" y="0"/>
+          <a:chExt cx="0" cy="0"/>
+        </a:xfrm>
+      </p:grpSpPr>
+      <p:pic>
+        <p:nvPicPr>
+          <p:cNvPr id="7" name="Picture 6" descr="A picture containing group, colorful">
+            <a:extLst>
+              <a:ext uri="{FF2B5EF4-FFF2-40B4-BE49-F238E27FC236}">
+                <a16:creationId xmlns:a16="http://schemas.microsoft.com/office/drawing/2014/main" id="{13DB4AD8-CB41-EC24-00CD-B566E1D1D64B}"/>
+              </a:ext>
+            </a:extLst>
+          </p:cNvPr>
+          <p:cNvPicPr>
+            <a:picLocks noChangeAspect="1"/>
+          </p:cNvPicPr>
+          <p:nvPr/>
+        </p:nvPicPr>
+        <p:blipFill>
+          <a:blip r:embed="rId2">
+            <a:extLst>
+              <a:ext uri="{28A0092B-C50C-407E-A947-70E740481C1C}">
+                <a14:useLocalDpi xmlns:a14="http://schemas.microsoft.com/office/drawing/2010/main" val="0"/>
+              </a:ext>
+            </a:extLst>
+          </a:blip>
+          <a:stretch>
+            <a:fillRect/>
+          </a:stretch>
+        </p:blipFill>
+        <p:spPr>
+          <a:xfrm>
+            <a:off x="0" y="0"/>
+            <a:ext cx="9144000" cy="1343891"/>
+          </a:xfrm>
+          <a:prstGeom prst="rect">
+            <a:avLst/>
+          </a:prstGeom>
+        </p:spPr>
+      </p:pic>
+      <p:sp>
+        <p:nvSpPr>
+          <p:cNvPr id="8" name="TextBox 7">
+            <a:extLst>
+              <a:ext uri="{FF2B5EF4-FFF2-40B4-BE49-F238E27FC236}">
+                <a16:creationId xmlns:a16="http://schemas.microsoft.com/office/drawing/2014/main" id="{755749A2-DE33-F98A-5C81-B639855D7937}"/>
+              </a:ext>
+            </a:extLst>
+          </p:cNvPr>
+          <p:cNvSpPr txBox="1"/>
+          <p:nvPr/>
+        </p:nvSpPr>
+        <p:spPr>
+          <a:xfrm>
+            <a:off x="2207936" y="6411247"/>
+            <a:ext cx="4728129" cy="307777"/>
+          </a:xfrm>
+          <a:prstGeom prst="rect">
+            <a:avLst/>
+          </a:prstGeom>
+          <a:solidFill>
+            <a:schemeClr val="bg1"/>
+          </a:solidFill>
+          <a:ln>
+            <a:solidFill>
+              <a:schemeClr val="tx1"/>
+            </a:solidFill>
+          </a:ln>
+        </p:spPr>
+        <p:txBody>
+          <a:bodyPr wrap="square" rtlCol="0">
+            <a:spAutoFit/>
+          </a:bodyPr>
+          <a:lstStyle/>
+          <a:p>
+            <a:pPr algn="ctr"/>
+            <a:r>
+              <a:rPr lang="en-US" sz="1400" dirty="0">
+                <a:solidFill>
+                  <a:srgbClr val="C00000"/>
+                </a:solidFill>
+              </a:rPr>
+              <a:t>Controlled Unclassified Information (CUI)</a:t>
+            </a:r>
+          </a:p>
+        </p:txBody>
+      </p:sp>
+      <p:sp>
+        <p:nvSpPr>
+          <p:cNvPr id="9" name="TextBox 8">
+            <a:extLst>
+              <a:ext uri="{FF2B5EF4-FFF2-40B4-BE49-F238E27FC236}">
+                <a16:creationId xmlns:a16="http://schemas.microsoft.com/office/drawing/2014/main" id="{81F60747-66AA-C6D2-6525-DC3B08C7628A}"/>
+              </a:ext>
+            </a:extLst>
+          </p:cNvPr>
+          <p:cNvSpPr txBox="1"/>
+          <p:nvPr/>
+        </p:nvSpPr>
+        <p:spPr>
+          <a:xfrm>
+            <a:off x="2207936" y="36576"/>
+            <a:ext cx="4728129" cy="307777"/>
+          </a:xfrm>
+          <a:prstGeom prst="rect">
+            <a:avLst/>
+          </a:prstGeom>
+          <a:solidFill>
+            <a:schemeClr val="bg1"/>
+          </a:solidFill>
+          <a:ln>
+            <a:solidFill>
+              <a:schemeClr val="tx1"/>
+            </a:solidFill>
+          </a:ln>
+        </p:spPr>
+        <p:txBody>
+          <a:bodyPr wrap="square" rtlCol="0">
+            <a:spAutoFit/>
+          </a:bodyPr>
+          <a:lstStyle/>
+          <a:p>
+            <a:pPr algn="ctr"/>
+            <a:r>
+              <a:rPr lang="en-US" sz="1400" dirty="0">
+                <a:solidFill>
+                  <a:srgbClr val="C00000"/>
+                </a:solidFill>
+              </a:rPr>
+              <a:t>Controlled Unclassified Information (CUI)</a:t>
+            </a:r>
+          </a:p>
+        </p:txBody>
+      </p:sp>
+    </p:spTree>
+    <p:extLst>
+      <p:ext uri="{BB962C8B-B14F-4D97-AF65-F5344CB8AC3E}">
+        <p14:creationId xmlns:p14="http://schemas.microsoft.com/office/powerpoint/2010/main" val="123626895"/>
+      </p:ext>
+    </p:extLst>
+  </p:cSld>
+  <p:clrMapOvr>
+    <a:masterClrMapping/>
+  </p:clrMapOvr>
+</p:sld>
+</file>
+
+<file path=ppt/slides/slide4.xml><?xml version="1.0" encoding="utf-8"?>
+<p:sld xmlns:a="http://schemas.openxmlformats.org/drawingml/2006/main" xmlns:r="http://schemas.openxmlformats.org/officeDocument/2006/relationships" xmlns:p="http://schemas.openxmlformats.org/presentationml/2006/main">
+  <p:cSld>
+    <p:spTree>
+      <p:nvGrpSpPr>
+        <p:cNvPr id="1" name="">
+          <a:extLst>
+            <a:ext uri="{FF2B5EF4-FFF2-40B4-BE49-F238E27FC236}">
+              <a16:creationId xmlns:a16="http://schemas.microsoft.com/office/drawing/2014/main" id="{E355D1E4-345D-DF28-3FDF-55E9484C6306}"/>
+            </a:ext>
+          </a:extLst>
+        </p:cNvPr>
+        <p:cNvGrpSpPr/>
+        <p:nvPr/>
+      </p:nvGrpSpPr>
+      <p:grpSpPr>
+        <a:xfrm>
+          <a:off x="0" y="0"/>
+          <a:ext cx="0" cy="0"/>
+          <a:chOff x="0" y="0"/>
+          <a:chExt cx="0" cy="0"/>
+        </a:xfrm>
+      </p:grpSpPr>
+      <p:pic>
+        <p:nvPicPr>
+          <p:cNvPr id="7" name="Picture 6" descr="A picture containing group, colorful">
+            <a:extLst>
+              <a:ext uri="{FF2B5EF4-FFF2-40B4-BE49-F238E27FC236}">
+                <a16:creationId xmlns:a16="http://schemas.microsoft.com/office/drawing/2014/main" id="{D1B88AAA-3454-B66D-432E-4286F61D6DFF}"/>
+              </a:ext>
+            </a:extLst>
+          </p:cNvPr>
+          <p:cNvPicPr>
+            <a:picLocks noChangeAspect="1"/>
+          </p:cNvPicPr>
+          <p:nvPr/>
+        </p:nvPicPr>
+        <p:blipFill>
+          <a:blip r:embed="rId2">
+            <a:extLst>
+              <a:ext uri="{28A0092B-C50C-407E-A947-70E740481C1C}">
+                <a14:useLocalDpi xmlns:a14="http://schemas.microsoft.com/office/drawing/2010/main" val="0"/>
+              </a:ext>
+            </a:extLst>
+          </a:blip>
+          <a:stretch>
+            <a:fillRect/>
+          </a:stretch>
+        </p:blipFill>
+        <p:spPr>
+          <a:xfrm>
+            <a:off x="0" y="0"/>
+            <a:ext cx="9144000" cy="1343891"/>
+          </a:xfrm>
+          <a:prstGeom prst="rect">
+            <a:avLst/>
+          </a:prstGeom>
+        </p:spPr>
+      </p:pic>
+      <p:sp>
+        <p:nvSpPr>
+          <p:cNvPr id="8" name="TextBox 7">
+            <a:extLst>
+              <a:ext uri="{FF2B5EF4-FFF2-40B4-BE49-F238E27FC236}">
+                <a16:creationId xmlns:a16="http://schemas.microsoft.com/office/drawing/2014/main" id="{A97126BE-48C8-8AFA-C09C-559531222B52}"/>
+              </a:ext>
+            </a:extLst>
+          </p:cNvPr>
+          <p:cNvSpPr txBox="1"/>
+          <p:nvPr/>
+        </p:nvSpPr>
+        <p:spPr>
+          <a:xfrm>
+            <a:off x="2207936" y="6411247"/>
+            <a:ext cx="4728129" cy="307777"/>
+          </a:xfrm>
+          <a:prstGeom prst="rect">
+            <a:avLst/>
+          </a:prstGeom>
+          <a:solidFill>
+            <a:schemeClr val="bg1"/>
+          </a:solidFill>
+          <a:ln>
+            <a:solidFill>
+              <a:schemeClr val="tx1"/>
+            </a:solidFill>
+          </a:ln>
+        </p:spPr>
+        <p:txBody>
+          <a:bodyPr wrap="square" rtlCol="0">
+            <a:spAutoFit/>
+          </a:bodyPr>
+          <a:lstStyle/>
+          <a:p>
+            <a:pPr algn="ctr"/>
+            <a:r>
+              <a:rPr lang="en-US" sz="1400" dirty="0">
+                <a:solidFill>
+                  <a:srgbClr val="C00000"/>
+                </a:solidFill>
+              </a:rPr>
+              <a:t>Controlled Unclassified Information (CUI)</a:t>
+            </a:r>
+          </a:p>
+        </p:txBody>
+      </p:sp>
+      <p:sp>
+        <p:nvSpPr>
+          <p:cNvPr id="9" name="TextBox 8">
+            <a:extLst>
+              <a:ext uri="{FF2B5EF4-FFF2-40B4-BE49-F238E27FC236}">
+                <a16:creationId xmlns:a16="http://schemas.microsoft.com/office/drawing/2014/main" id="{A4BDAA7B-9AF5-B942-F399-ACA7D3B5BAB5}"/>
+              </a:ext>
+            </a:extLst>
+          </p:cNvPr>
+          <p:cNvSpPr txBox="1"/>
+          <p:nvPr/>
+        </p:nvSpPr>
+        <p:spPr>
+          <a:xfrm>
+            <a:off x="2207936" y="36576"/>
+            <a:ext cx="4728129" cy="307777"/>
+          </a:xfrm>
+          <a:prstGeom prst="rect">
+            <a:avLst/>
+          </a:prstGeom>
+          <a:solidFill>
+            <a:schemeClr val="bg1"/>
+          </a:solidFill>
+          <a:ln>
+            <a:solidFill>
+              <a:schemeClr val="tx1"/>
+            </a:solidFill>
+          </a:ln>
+        </p:spPr>
+        <p:txBody>
+          <a:bodyPr wrap="square" rtlCol="0">
+            <a:spAutoFit/>
+          </a:bodyPr>
+          <a:lstStyle/>
+          <a:p>
+            <a:pPr algn="ctr"/>
+            <a:r>
+              <a:rPr lang="en-US" sz="1400" dirty="0">
+                <a:solidFill>
+                  <a:srgbClr val="C00000"/>
+                </a:solidFill>
+              </a:rPr>
+              <a:t>Controlled Unclassified Information (CUI)</a:t>
+            </a:r>
+          </a:p>
+        </p:txBody>
+      </p:sp>
+    </p:spTree>
+    <p:extLst>
+      <p:ext uri="{BB962C8B-B14F-4D97-AF65-F5344CB8AC3E}">
+        <p14:creationId xmlns:p14="http://schemas.microsoft.com/office/powerpoint/2010/main" val="464938641"/>
+      </p:ext>
+    </p:extLst>
+  </p:cSld>
+  <p:clrMapOvr>
+    <a:masterClrMapping/>
+  </p:clrMapOvr>
+</p:sld>
+</file>
+
+<file path=ppt/slides/slide5.xml><?xml version="1.0" encoding="utf-8"?>
+<p:sld xmlns:a="http://schemas.openxmlformats.org/drawingml/2006/main" xmlns:r="http://schemas.openxmlformats.org/officeDocument/2006/relationships" xmlns:p="http://schemas.openxmlformats.org/presentationml/2006/main">
+  <p:cSld>
+    <p:spTree>
+      <p:nvGrpSpPr>
+        <p:cNvPr id="1" name="">
+          <a:extLst>
+            <a:ext uri="{FF2B5EF4-FFF2-40B4-BE49-F238E27FC236}">
+              <a16:creationId xmlns:a16="http://schemas.microsoft.com/office/drawing/2014/main" id="{4F564D8D-E439-6EC4-8AC6-FC55A0CA536E}"/>
+            </a:ext>
+          </a:extLst>
+        </p:cNvPr>
+        <p:cNvGrpSpPr/>
+        <p:nvPr/>
+      </p:nvGrpSpPr>
+      <p:grpSpPr>
+        <a:xfrm>
+          <a:off x="0" y="0"/>
+          <a:ext cx="0" cy="0"/>
+          <a:chOff x="0" y="0"/>
+          <a:chExt cx="0" cy="0"/>
+        </a:xfrm>
+      </p:grpSpPr>
+      <p:pic>
+        <p:nvPicPr>
+          <p:cNvPr id="7" name="Picture 6" descr="A picture containing group, colorful">
+            <a:extLst>
+              <a:ext uri="{FF2B5EF4-FFF2-40B4-BE49-F238E27FC236}">
+                <a16:creationId xmlns:a16="http://schemas.microsoft.com/office/drawing/2014/main" id="{0BE61B86-E32B-79E1-9ED7-7F2094A78735}"/>
+              </a:ext>
+            </a:extLst>
+          </p:cNvPr>
+          <p:cNvPicPr>
+            <a:picLocks noChangeAspect="1"/>
+          </p:cNvPicPr>
+          <p:nvPr/>
+        </p:nvPicPr>
+        <p:blipFill>
+          <a:blip r:embed="rId2">
+            <a:extLst>
+              <a:ext uri="{28A0092B-C50C-407E-A947-70E740481C1C}">
+                <a14:useLocalDpi xmlns:a14="http://schemas.microsoft.com/office/drawing/2010/main" val="0"/>
+              </a:ext>
+            </a:extLst>
+          </a:blip>
+          <a:stretch>
+            <a:fillRect/>
+          </a:stretch>
+        </p:blipFill>
+        <p:spPr>
+          <a:xfrm>
+            <a:off x="0" y="0"/>
+            <a:ext cx="9144000" cy="1343891"/>
+          </a:xfrm>
+          <a:prstGeom prst="rect">
+            <a:avLst/>
+          </a:prstGeom>
+        </p:spPr>
+      </p:pic>
+      <p:sp>
+        <p:nvSpPr>
+          <p:cNvPr id="8" name="TextBox 7">
+            <a:extLst>
+              <a:ext uri="{FF2B5EF4-FFF2-40B4-BE49-F238E27FC236}">
+                <a16:creationId xmlns:a16="http://schemas.microsoft.com/office/drawing/2014/main" id="{FBE41D44-BD3B-4FB7-585E-108DF4F0D6BB}"/>
+              </a:ext>
+            </a:extLst>
+          </p:cNvPr>
+          <p:cNvSpPr txBox="1"/>
+          <p:nvPr/>
+        </p:nvSpPr>
+        <p:spPr>
+          <a:xfrm>
+            <a:off x="2207936" y="6411247"/>
+            <a:ext cx="4728129" cy="307777"/>
+          </a:xfrm>
+          <a:prstGeom prst="rect">
+            <a:avLst/>
+          </a:prstGeom>
+          <a:solidFill>
+            <a:schemeClr val="bg1"/>
+          </a:solidFill>
+          <a:ln>
+            <a:solidFill>
+              <a:schemeClr val="tx1"/>
+            </a:solidFill>
+          </a:ln>
+        </p:spPr>
+        <p:txBody>
+          <a:bodyPr wrap="square" rtlCol="0">
+            <a:spAutoFit/>
+          </a:bodyPr>
+          <a:lstStyle/>
+          <a:p>
+            <a:pPr algn="ctr"/>
+            <a:r>
+              <a:rPr lang="en-US" sz="1400" dirty="0">
+                <a:solidFill>
+                  <a:srgbClr val="C00000"/>
+                </a:solidFill>
+              </a:rPr>
+              <a:t>Controlled Unclassified Information (CUI)</a:t>
+            </a:r>
+          </a:p>
+        </p:txBody>
+      </p:sp>
+      <p:sp>
+        <p:nvSpPr>
+          <p:cNvPr id="9" name="TextBox 8">
+            <a:extLst>
+              <a:ext uri="{FF2B5EF4-FFF2-40B4-BE49-F238E27FC236}">
+                <a16:creationId xmlns:a16="http://schemas.microsoft.com/office/drawing/2014/main" id="{44FA64D1-0079-57F1-2028-02E02B05BD8C}"/>
+              </a:ext>
+            </a:extLst>
+          </p:cNvPr>
+          <p:cNvSpPr txBox="1"/>
+          <p:nvPr/>
+        </p:nvSpPr>
+        <p:spPr>
+          <a:xfrm>
+            <a:off x="2207936" y="36576"/>
+            <a:ext cx="4728129" cy="307777"/>
+          </a:xfrm>
+          <a:prstGeom prst="rect">
+            <a:avLst/>
+          </a:prstGeom>
+          <a:solidFill>
+            <a:schemeClr val="bg1"/>
+          </a:solidFill>
+          <a:ln>
+            <a:solidFill>
+              <a:schemeClr val="tx1"/>
+            </a:solidFill>
+          </a:ln>
+        </p:spPr>
+        <p:txBody>
+          <a:bodyPr wrap="square" rtlCol="0">
+            <a:spAutoFit/>
+          </a:bodyPr>
+          <a:lstStyle/>
+          <a:p>
+            <a:pPr algn="ctr"/>
+            <a:r>
+              <a:rPr lang="en-US" sz="1400" dirty="0">
+                <a:solidFill>
+                  <a:srgbClr val="C00000"/>
+                </a:solidFill>
+              </a:rPr>
+              <a:t>Controlled Unclassified Information (CUI)</a:t>
+            </a:r>
+          </a:p>
+        </p:txBody>
+      </p:sp>
+    </p:spTree>
+    <p:extLst>
+      <p:ext uri="{BB962C8B-B14F-4D97-AF65-F5344CB8AC3E}">
+        <p14:creationId xmlns:p14="http://schemas.microsoft.com/office/powerpoint/2010/main" val="3753486991"/>
+      </p:ext>
+    </p:extLst>
+  </p:cSld>
+  <p:clrMapOvr>
+    <a:masterClrMapping/>
+  </p:clrMapOvr>
+</p:sld>
+</file>
+
 <file path=ppt/theme/theme1.xml><?xml version="1.0" encoding="utf-8"?>
 <a:theme xmlns:a="http://schemas.openxmlformats.org/drawingml/2006/main" name="Office Theme">
   <a:themeElements>

</xml_diff>